<commit_message>
committing changes for safety net before big changes
</commit_message>
<xml_diff>
--- a/docs/presentations/Lithium Extraction with ePC-SAFT.pptx
+++ b/docs/presentations/Lithium Extraction with ePC-SAFT.pptx
@@ -254,7 +254,7 @@
             <a:fld id="{154CA9B8-74BC-42CC-8AD2-E73F5E847AA6}" type="datetimeFigureOut">
               <a:rPr lang="en-US" smtClean="0"/>
               <a:pPr/>
-              <a:t>02/13/26</a:t>
+              <a:t>03/17/26</a:t>
             </a:fld>
             <a:endParaRPr lang="en-US"/>
           </a:p>
@@ -421,7 +421,7 @@
             <a:fld id="{010CAAA1-2DC6-469D-86AF-311C333CDD14}" type="datetimeFigureOut">
               <a:rPr lang="en-US" smtClean="0"/>
               <a:pPr/>
-              <a:t>02/13/26</a:t>
+              <a:t>03/17/26</a:t>
             </a:fld>
             <a:endParaRPr lang="en-US"/>
           </a:p>
@@ -5951,7 +5951,7 @@
             <a:fld id="{6C882809-195B-4C71-AF45-AF8015062DE4}" type="datetimeFigureOut">
               <a:rPr lang="en-US" smtClean="0"/>
               <a:pPr/>
-              <a:t>02/13/26</a:t>
+              <a:t>03/17/26</a:t>
             </a:fld>
             <a:endParaRPr lang="en-US" dirty="0"/>
           </a:p>
@@ -7704,7 +7704,7 @@
         </p:blipFill>
         <p:spPr>
           <a:xfrm>
-            <a:off x="0" y="861248"/>
+            <a:off x="35181" y="861248"/>
             <a:ext cx="3875315" cy="2691191"/>
           </a:xfrm>
           <a:prstGeom prst="rect">
@@ -7734,7 +7734,7 @@
         </p:blipFill>
         <p:spPr>
           <a:xfrm>
-            <a:off x="3785644" y="790944"/>
+            <a:off x="3803234" y="826096"/>
             <a:ext cx="4077788" cy="2831798"/>
           </a:xfrm>
           <a:prstGeom prst="rect">
@@ -7824,7 +7824,7 @@
         </p:blipFill>
         <p:spPr>
           <a:xfrm>
-            <a:off x="4035348" y="3519798"/>
+            <a:off x="4064507" y="3519798"/>
             <a:ext cx="3668050" cy="2547257"/>
           </a:xfrm>
           <a:prstGeom prst="rect">
@@ -12967,12 +12967,9 @@
 </file>
 
 <file path=customXml/item1.xml><?xml version="1.0" encoding="utf-8"?>
-<?mso-contentType ?>
-<FormTemplates xmlns="http://schemas.microsoft.com/sharepoint/v3/contenttype/forms">
-  <Display>DocumentLibraryForm</Display>
-  <Edit>DocumentLibraryForm</Edit>
-  <New>DocumentLibraryForm</New>
-</FormTemplates>
+<p:properties xmlns:p="http://schemas.microsoft.com/office/2006/metadata/properties" xmlns:xsi="http://www.w3.org/2001/XMLSchema-instance" xmlns:pc="http://schemas.microsoft.com/office/infopath/2007/PartnerControls">
+  <documentManagement/>
+</p:properties>
 </file>
 
 <file path=customXml/item2.xml><?xml version="1.0" encoding="utf-8"?>
@@ -13090,15 +13087,25 @@
 </file>
 
 <file path=customXml/item3.xml><?xml version="1.0" encoding="utf-8"?>
-<p:properties xmlns:p="http://schemas.microsoft.com/office/2006/metadata/properties" xmlns:xsi="http://www.w3.org/2001/XMLSchema-instance" xmlns:pc="http://schemas.microsoft.com/office/infopath/2007/PartnerControls">
-  <documentManagement/>
-</p:properties>
+<?mso-contentType ?>
+<FormTemplates xmlns="http://schemas.microsoft.com/sharepoint/v3/contenttype/forms">
+  <Display>DocumentLibraryForm</Display>
+  <Edit>DocumentLibraryForm</Edit>
+  <New>DocumentLibraryForm</New>
+</FormTemplates>
 </file>
 
 <file path=customXml/itemProps1.xml><?xml version="1.0" encoding="utf-8"?>
-<ds:datastoreItem xmlns:ds="http://schemas.openxmlformats.org/officeDocument/2006/customXml" ds:itemID="{A22840F2-5BB0-45AB-A8DF-9A97CD9488E4}">
+<ds:datastoreItem xmlns:ds="http://schemas.openxmlformats.org/officeDocument/2006/customXml" ds:itemID="{ED0DB2A8-98EE-4CA5-9B57-4F5F6858EA16}">
   <ds:schemaRefs>
-    <ds:schemaRef ds:uri="http://schemas.microsoft.com/sharepoint/v3/contenttype/forms"/>
+    <ds:schemaRef ds:uri="http://schemas.microsoft.com/office/2006/metadata/properties"/>
+    <ds:schemaRef ds:uri="http://purl.org/dc/terms/"/>
+    <ds:schemaRef ds:uri="http://schemas.microsoft.com/office/2006/documentManagement/types"/>
+    <ds:schemaRef ds:uri="http://schemas.openxmlformats.org/package/2006/metadata/core-properties"/>
+    <ds:schemaRef ds:uri="http://purl.org/dc/elements/1.1/"/>
+    <ds:schemaRef ds:uri="http://schemas.microsoft.com/office/infopath/2007/PartnerControls"/>
+    <ds:schemaRef ds:uri="http://www.w3.org/XML/1998/namespace"/>
+    <ds:schemaRef ds:uri="http://purl.org/dc/dcmitype/"/>
   </ds:schemaRefs>
 </ds:datastoreItem>
 </file>
@@ -13120,16 +13127,9 @@
 </file>
 
 <file path=customXml/itemProps3.xml><?xml version="1.0" encoding="utf-8"?>
-<ds:datastoreItem xmlns:ds="http://schemas.openxmlformats.org/officeDocument/2006/customXml" ds:itemID="{ED0DB2A8-98EE-4CA5-9B57-4F5F6858EA16}">
+<ds:datastoreItem xmlns:ds="http://schemas.openxmlformats.org/officeDocument/2006/customXml" ds:itemID="{A22840F2-5BB0-45AB-A8DF-9A97CD9488E4}">
   <ds:schemaRefs>
-    <ds:schemaRef ds:uri="http://schemas.microsoft.com/office/2006/metadata/properties"/>
-    <ds:schemaRef ds:uri="http://purl.org/dc/terms/"/>
-    <ds:schemaRef ds:uri="http://schemas.microsoft.com/office/2006/documentManagement/types"/>
-    <ds:schemaRef ds:uri="http://schemas.openxmlformats.org/package/2006/metadata/core-properties"/>
-    <ds:schemaRef ds:uri="http://purl.org/dc/elements/1.1/"/>
-    <ds:schemaRef ds:uri="http://schemas.microsoft.com/office/infopath/2007/PartnerControls"/>
-    <ds:schemaRef ds:uri="http://www.w3.org/XML/1998/namespace"/>
-    <ds:schemaRef ds:uri="http://purl.org/dc/dcmitype/"/>
+    <ds:schemaRef ds:uri="http://schemas.microsoft.com/sharepoint/v3/contenttype/forms"/>
   </ds:schemaRefs>
 </ds:datastoreItem>
 </file>
</xml_diff>